<commit_message>
add package-all command and GitHub Release workflow for claude.ai distribution
- Introduce `package-all` subcommand in tools/build_skill.py to zip every skill via claude_ai profile
- Add .github/workflows/release.yml to publish dist/*.zip on tag push / manual dispatch
- Replace hardcoded /home/claude and /mnt/user-data/outputs paths across SKILL.md files with {{WORK_DIR}} / {{OUTPUT_DIR}} template variables so both Claude Code and Claude.ai profiles resolve correctly
- Update company-overview-pptx-v2 template and fill script; extend issue-risk-list fill script

Co-Authored-By: Claude Opus 4.7 (1M context) <noreply@anthropic.com>
</commit_message>
<xml_diff>
--- a/skills/company-overview-pptx-v2/assets/company-overview-template.pptx
+++ b/skills/company-overview-pptx-v2/assets/company-overview-template.pptx
@@ -698,75 +698,6 @@
           <a:chExt cx="0" cy="0"/>
         </a:xfrm>
       </p:grpSpPr>
-      <p:graphicFrame>
-        <p:nvGraphicFramePr>
-          <p:cNvPr id="9" name="think-cell data - do not delete" hidden="1">
-            <a:extLst>
-              <a:ext uri="{FF2B5EF4-FFF2-40B4-BE49-F238E27FC236}">
-                <a16:creationId xmlns:a16="http://schemas.microsoft.com/office/drawing/2014/main" id="{26A9CB88-735E-6849-3DE2-E60599824D0A}"/>
-              </a:ext>
-            </a:extLst>
-          </p:cNvPr>
-          <p:cNvGraphicFramePr>
-            <a:graphicFrameLocks noChangeAspect="1"/>
-          </p:cNvGraphicFramePr>
-          <p:nvPr userDrawn="1">
-            <p:extLst>
-              <p:ext uri="{D42A27DB-BD31-4B8C-83A1-F6EECF244321}">
-                <p14:modId xmlns:p14="http://schemas.microsoft.com/office/powerpoint/2010/main" val="1511893759"/>
-              </p:ext>
-            </p:extLst>
-          </p:nvPr>
-        </p:nvGraphicFramePr>
-        <p:xfrm>
-          <a:off x="1588" y="1588"/>
-          <a:ext cx="1227" cy="1588"/>
-        </p:xfrm>
-        <a:graphic>
-          <a:graphicData uri="http://schemas.openxmlformats.org/presentationml/2006/ole">
-            <mc:AlternateContent xmlns:mc="http://schemas.openxmlformats.org/markup-compatibility/2006">
-              <mc:Choice xmlns:v="urn:schemas-microsoft-com:vml" Requires="v">
-                <p:oleObj name="think-cell Slide" r:id="rId2" imgW="7772400" imgH="10058400" progId="TCLayout.ActiveDocument.1">
-                  <p:embed/>
-                </p:oleObj>
-              </mc:Choice>
-              <mc:Fallback>
-                <p:oleObj name="think-cell Slide" r:id="rId2" imgW="7772400" imgH="10058400" progId="TCLayout.ActiveDocument.1">
-                  <p:embed/>
-                  <p:pic>
-                    <p:nvPicPr>
-                      <p:cNvPr id="9" name="think-cell data - do not delete" hidden="1">
-                        <a:extLst>
-                          <a:ext uri="{FF2B5EF4-FFF2-40B4-BE49-F238E27FC236}">
-                            <a16:creationId xmlns:a16="http://schemas.microsoft.com/office/drawing/2014/main" id="{26A9CB88-735E-6849-3DE2-E60599824D0A}"/>
-                          </a:ext>
-                        </a:extLst>
-                      </p:cNvPr>
-                      <p:cNvPicPr/>
-                      <p:nvPr/>
-                    </p:nvPicPr>
-                    <p:blipFill>
-                      <a:blip r:embed="rId3"/>
-                      <a:stretch>
-                        <a:fillRect/>
-                      </a:stretch>
-                    </p:blipFill>
-                    <p:spPr>
-                      <a:xfrm>
-                        <a:off x="1588" y="1588"/>
-                        <a:ext cx="1227" cy="1588"/>
-                      </a:xfrm>
-                      <a:prstGeom prst="rect">
-                        <a:avLst/>
-                      </a:prstGeom>
-                    </p:spPr>
-                  </p:pic>
-                </p:oleObj>
-              </mc:Fallback>
-            </mc:AlternateContent>
-          </a:graphicData>
-        </a:graphic>
-      </p:graphicFrame>
       <p:sp>
         <p:nvSpPr>
           <p:cNvPr id="7" name="テキスト ボックス 6">
@@ -1397,69 +1328,6 @@
           <a:chExt cx="0" cy="0"/>
         </a:xfrm>
       </p:grpSpPr>
-      <p:graphicFrame>
-        <p:nvGraphicFramePr>
-          <p:cNvPr id="7" name="think-cell data - do not delete" hidden="1">
-            <a:extLst>
-              <a:ext uri="{FF2B5EF4-FFF2-40B4-BE49-F238E27FC236}">
-                <a16:creationId xmlns:a16="http://schemas.microsoft.com/office/drawing/2014/main" id="{2366C2E6-77B5-C628-99E9-2719E9BB1B9A}"/>
-              </a:ext>
-            </a:extLst>
-          </p:cNvPr>
-          <p:cNvGraphicFramePr>
-            <a:graphicFrameLocks noChangeAspect="1"/>
-          </p:cNvGraphicFramePr>
-          <p:nvPr userDrawn="1"/>
-        </p:nvGraphicFramePr>
-        <p:xfrm>
-          <a:off x="1588" y="1588"/>
-          <a:ext cx="1227" cy="1588"/>
-        </p:xfrm>
-        <a:graphic>
-          <a:graphicData uri="http://schemas.openxmlformats.org/presentationml/2006/ole">
-            <mc:AlternateContent xmlns:mc="http://schemas.openxmlformats.org/markup-compatibility/2006">
-              <mc:Choice xmlns:v="urn:schemas-microsoft-com:vml" Requires="v">
-                <p:oleObj name="think-cell Slide" r:id="rId2" imgW="7772400" imgH="10058400" progId="TCLayout.ActiveDocument.1">
-                  <p:embed/>
-                </p:oleObj>
-              </mc:Choice>
-              <mc:Fallback>
-                <p:oleObj name="think-cell Slide" r:id="rId2" imgW="7772400" imgH="10058400" progId="TCLayout.ActiveDocument.1">
-                  <p:embed/>
-                  <p:pic>
-                    <p:nvPicPr>
-                      <p:cNvPr id="7" name="think-cell data - do not delete" hidden="1">
-                        <a:extLst>
-                          <a:ext uri="{FF2B5EF4-FFF2-40B4-BE49-F238E27FC236}">
-                            <a16:creationId xmlns:a16="http://schemas.microsoft.com/office/drawing/2014/main" id="{2366C2E6-77B5-C628-99E9-2719E9BB1B9A}"/>
-                          </a:ext>
-                        </a:extLst>
-                      </p:cNvPr>
-                      <p:cNvPicPr/>
-                      <p:nvPr/>
-                    </p:nvPicPr>
-                    <p:blipFill>
-                      <a:blip r:embed="rId3"/>
-                      <a:stretch>
-                        <a:fillRect/>
-                      </a:stretch>
-                    </p:blipFill>
-                    <p:spPr>
-                      <a:xfrm>
-                        <a:off x="1588" y="1588"/>
-                        <a:ext cx="1227" cy="1588"/>
-                      </a:xfrm>
-                      <a:prstGeom prst="rect">
-                        <a:avLst/>
-                      </a:prstGeom>
-                    </p:spPr>
-                  </p:pic>
-                </p:oleObj>
-              </mc:Fallback>
-            </mc:AlternateContent>
-          </a:graphicData>
-        </a:graphic>
-      </p:graphicFrame>
       <p:sp>
         <p:nvSpPr>
           <p:cNvPr id="3" name="タイトル 1">
@@ -1584,69 +1452,6 @@
           <a:chExt cx="0" cy="0"/>
         </a:xfrm>
       </p:grpSpPr>
-      <p:graphicFrame>
-        <p:nvGraphicFramePr>
-          <p:cNvPr id="7" name="think-cell data - do not delete" hidden="1">
-            <a:extLst>
-              <a:ext uri="{FF2B5EF4-FFF2-40B4-BE49-F238E27FC236}">
-                <a16:creationId xmlns:a16="http://schemas.microsoft.com/office/drawing/2014/main" id="{2366C2E6-77B5-C628-99E9-2719E9BB1B9A}"/>
-              </a:ext>
-            </a:extLst>
-          </p:cNvPr>
-          <p:cNvGraphicFramePr>
-            <a:graphicFrameLocks noChangeAspect="1"/>
-          </p:cNvGraphicFramePr>
-          <p:nvPr userDrawn="1"/>
-        </p:nvGraphicFramePr>
-        <p:xfrm>
-          <a:off x="1588" y="1588"/>
-          <a:ext cx="1227" cy="1588"/>
-        </p:xfrm>
-        <a:graphic>
-          <a:graphicData uri="http://schemas.openxmlformats.org/presentationml/2006/ole">
-            <mc:AlternateContent xmlns:mc="http://schemas.openxmlformats.org/markup-compatibility/2006">
-              <mc:Choice xmlns:v="urn:schemas-microsoft-com:vml" Requires="v">
-                <p:oleObj name="think-cell Slide" r:id="rId2" imgW="7772400" imgH="10058400" progId="TCLayout.ActiveDocument.1">
-                  <p:embed/>
-                </p:oleObj>
-              </mc:Choice>
-              <mc:Fallback>
-                <p:oleObj name="think-cell Slide" r:id="rId2" imgW="7772400" imgH="10058400" progId="TCLayout.ActiveDocument.1">
-                  <p:embed/>
-                  <p:pic>
-                    <p:nvPicPr>
-                      <p:cNvPr id="7" name="think-cell data - do not delete" hidden="1">
-                        <a:extLst>
-                          <a:ext uri="{FF2B5EF4-FFF2-40B4-BE49-F238E27FC236}">
-                            <a16:creationId xmlns:a16="http://schemas.microsoft.com/office/drawing/2014/main" id="{2366C2E6-77B5-C628-99E9-2719E9BB1B9A}"/>
-                          </a:ext>
-                        </a:extLst>
-                      </p:cNvPr>
-                      <p:cNvPicPr/>
-                      <p:nvPr/>
-                    </p:nvPicPr>
-                    <p:blipFill>
-                      <a:blip r:embed="rId3"/>
-                      <a:stretch>
-                        <a:fillRect/>
-                      </a:stretch>
-                    </p:blipFill>
-                    <p:spPr>
-                      <a:xfrm>
-                        <a:off x="1588" y="1588"/>
-                        <a:ext cx="1227" cy="1588"/>
-                      </a:xfrm>
-                      <a:prstGeom prst="rect">
-                        <a:avLst/>
-                      </a:prstGeom>
-                    </p:spPr>
-                  </p:pic>
-                </p:oleObj>
-              </mc:Fallback>
-            </mc:AlternateContent>
-          </a:graphicData>
-        </a:graphic>
-      </p:graphicFrame>
       <p:sp>
         <p:nvSpPr>
           <p:cNvPr id="3" name="タイトル 1">
@@ -1779,75 +1584,6 @@
           <a:chExt cx="0" cy="0"/>
         </a:xfrm>
       </p:grpSpPr>
-      <p:graphicFrame>
-        <p:nvGraphicFramePr>
-          <p:cNvPr id="6" name="think-cell data - do not delete" hidden="1">
-            <a:extLst>
-              <a:ext uri="{FF2B5EF4-FFF2-40B4-BE49-F238E27FC236}">
-                <a16:creationId xmlns:a16="http://schemas.microsoft.com/office/drawing/2014/main" id="{10807434-350C-4893-6E94-4C9EB9C03B8B}"/>
-              </a:ext>
-            </a:extLst>
-          </p:cNvPr>
-          <p:cNvGraphicFramePr>
-            <a:graphicFrameLocks noChangeAspect="1"/>
-          </p:cNvGraphicFramePr>
-          <p:nvPr userDrawn="1">
-            <p:extLst>
-              <p:ext uri="{D42A27DB-BD31-4B8C-83A1-F6EECF244321}">
-                <p14:modId xmlns:p14="http://schemas.microsoft.com/office/powerpoint/2010/main" val="3709712828"/>
-              </p:ext>
-            </p:extLst>
-          </p:nvPr>
-        </p:nvGraphicFramePr>
-        <p:xfrm>
-          <a:off x="1588" y="1588"/>
-          <a:ext cx="1227" cy="1588"/>
-        </p:xfrm>
-        <a:graphic>
-          <a:graphicData uri="http://schemas.openxmlformats.org/presentationml/2006/ole">
-            <mc:AlternateContent xmlns:mc="http://schemas.openxmlformats.org/markup-compatibility/2006">
-              <mc:Choice xmlns:v="urn:schemas-microsoft-com:vml" Requires="v">
-                <p:oleObj name="think-cell Slide" r:id="rId7" imgW="7772400" imgH="10058400" progId="TCLayout.ActiveDocument.1">
-                  <p:embed/>
-                </p:oleObj>
-              </mc:Choice>
-              <mc:Fallback>
-                <p:oleObj name="think-cell Slide" r:id="rId7" imgW="7772400" imgH="10058400" progId="TCLayout.ActiveDocument.1">
-                  <p:embed/>
-                  <p:pic>
-                    <p:nvPicPr>
-                      <p:cNvPr id="6" name="think-cell data - do not delete" hidden="1">
-                        <a:extLst>
-                          <a:ext uri="{FF2B5EF4-FFF2-40B4-BE49-F238E27FC236}">
-                            <a16:creationId xmlns:a16="http://schemas.microsoft.com/office/drawing/2014/main" id="{10807434-350C-4893-6E94-4C9EB9C03B8B}"/>
-                          </a:ext>
-                        </a:extLst>
-                      </p:cNvPr>
-                      <p:cNvPicPr/>
-                      <p:nvPr/>
-                    </p:nvPicPr>
-                    <p:blipFill>
-                      <a:blip r:embed="rId8"/>
-                      <a:stretch>
-                        <a:fillRect/>
-                      </a:stretch>
-                    </p:blipFill>
-                    <p:spPr>
-                      <a:xfrm>
-                        <a:off x="1588" y="1588"/>
-                        <a:ext cx="1227" cy="1588"/>
-                      </a:xfrm>
-                      <a:prstGeom prst="rect">
-                        <a:avLst/>
-                      </a:prstGeom>
-                    </p:spPr>
-                  </p:pic>
-                </p:oleObj>
-              </mc:Fallback>
-            </mc:AlternateContent>
-          </a:graphicData>
-        </a:graphic>
-      </p:graphicFrame>
       <p:sp>
         <p:nvSpPr>
           <p:cNvPr id="2" name="タイトル プレースホルダー 1">
@@ -2477,78 +2213,6 @@
           <a:chExt cx="0" cy="0"/>
         </a:xfrm>
       </p:grpSpPr>
-      <p:graphicFrame>
-        <p:nvGraphicFramePr>
-          <p:cNvPr id="8" name="think-cell data - do not delete" hidden="1">
-            <a:extLst>
-              <a:ext uri="{FF2B5EF4-FFF2-40B4-BE49-F238E27FC236}">
-                <a16:creationId xmlns:a16="http://schemas.microsoft.com/office/drawing/2014/main" id="{8B876925-78A3-0D6D-A136-2CE4548C6FDC}"/>
-              </a:ext>
-            </a:extLst>
-          </p:cNvPr>
-          <p:cNvGraphicFramePr>
-            <a:graphicFrameLocks noChangeAspect="1"/>
-          </p:cNvGraphicFramePr>
-          <p:nvPr>
-            <p:custDataLst>
-              <p:tags r:id="rId1"/>
-            </p:custDataLst>
-            <p:extLst>
-              <p:ext uri="{D42A27DB-BD31-4B8C-83A1-F6EECF244321}">
-                <p14:modId xmlns:p14="http://schemas.microsoft.com/office/powerpoint/2010/main" val="272350908"/>
-              </p:ext>
-            </p:extLst>
-          </p:nvPr>
-        </p:nvGraphicFramePr>
-        <p:xfrm>
-          <a:off x="1588" y="1588"/>
-          <a:ext cx="1227" cy="1588"/>
-        </p:xfrm>
-        <a:graphic>
-          <a:graphicData uri="http://schemas.openxmlformats.org/presentationml/2006/ole">
-            <mc:AlternateContent xmlns:mc="http://schemas.openxmlformats.org/markup-compatibility/2006">
-              <mc:Choice xmlns:v="urn:schemas-microsoft-com:vml" Requires="v">
-                <p:oleObj name="think-cell Slide" r:id="rId3" imgW="7772400" imgH="10058400" progId="TCLayout.ActiveDocument.1">
-                  <p:embed/>
-                </p:oleObj>
-              </mc:Choice>
-              <mc:Fallback>
-                <p:oleObj name="think-cell Slide" r:id="rId3" imgW="7772400" imgH="10058400" progId="TCLayout.ActiveDocument.1">
-                  <p:embed/>
-                  <p:pic>
-                    <p:nvPicPr>
-                      <p:cNvPr id="8" name="think-cell data - do not delete" hidden="1">
-                        <a:extLst>
-                          <a:ext uri="{FF2B5EF4-FFF2-40B4-BE49-F238E27FC236}">
-                            <a16:creationId xmlns:a16="http://schemas.microsoft.com/office/drawing/2014/main" id="{8B876925-78A3-0D6D-A136-2CE4548C6FDC}"/>
-                          </a:ext>
-                        </a:extLst>
-                      </p:cNvPr>
-                      <p:cNvPicPr/>
-                      <p:nvPr/>
-                    </p:nvPicPr>
-                    <p:blipFill>
-                      <a:blip r:embed="rId4"/>
-                      <a:stretch>
-                        <a:fillRect/>
-                      </a:stretch>
-                    </p:blipFill>
-                    <p:spPr>
-                      <a:xfrm>
-                        <a:off x="1588" y="1588"/>
-                        <a:ext cx="1227" cy="1588"/>
-                      </a:xfrm>
-                      <a:prstGeom prst="rect">
-                        <a:avLst/>
-                      </a:prstGeom>
-                    </p:spPr>
-                  </p:pic>
-                </p:oleObj>
-              </mc:Fallback>
-            </mc:AlternateContent>
-          </a:graphicData>
-        </a:graphic>
-      </p:graphicFrame>
       <p:sp>
         <p:nvSpPr>
           <p:cNvPr id="2" name="Title 1">

</xml_diff>